<commit_message>
Freeze GEH v4 as the quality benchmark
- Layout audit in the renderer: overflow, off-slide, text collisions, one-line
  elements that wrap, orphaned title words; the deck is not written if any fail.
- deck_rubric.py: the cold CXO review as rules (addressable value base, credentials
  early, no fee in the ask, no pre-ranked placeholders, tone; scored soft rules).
- build_deck.py: one command, every gate in order.
- Golden snapshot of the v4 benchmark, rubric/audit regression tests, and a
  deck-report check that every deck number appears in the report.
- docs/quality-bar.md: the bar, the build, and the repeatable cold-review brief.
- Fix: summary tile label overflowed its box (caught by the new audit).

Co-Authored-By: Claude Opus 5.5 <noreply@anthropic.com>
Claude-Session: https://claude.ai/code/session_018KHaDbrN1SxJ7Wg1B8C577
</commit_message>
<xml_diff>
--- a/runs/great-eastern/2026-10-26-run6/deck-exec-v4/PLUMB-GEH-preread-v4-DRAFT.pptx
+++ b/runs/great-eastern/2026-10-26-run6/deck-exec-v4/PLUMB-GEH-preread-v4-DRAFT.pptx
@@ -4150,7 +4150,7 @@
         <p:spPr>
           <a:xfrm>
             <a:off x="548640" y="1554480"/>
-            <a:ext cx="3515258" cy="2880360"/>
+            <a:ext cx="3515258" cy="3063240"/>
           </a:xfrm>
           <a:prstGeom prst="rect">
             <a:avLst/>
@@ -4263,7 +4263,7 @@
         <p:spPr>
           <a:xfrm>
             <a:off x="932688" y="3703320"/>
-            <a:ext cx="2747162" cy="594360"/>
+            <a:ext cx="2747162" cy="731520"/>
           </a:xfrm>
           <a:prstGeom prst="rect">
             <a:avLst/>
@@ -4302,7 +4302,7 @@
         <p:spPr>
           <a:xfrm>
             <a:off x="4338218" y="1554480"/>
-            <a:ext cx="3515258" cy="2880360"/>
+            <a:ext cx="3515258" cy="3063240"/>
           </a:xfrm>
           <a:prstGeom prst="rect">
             <a:avLst/>
@@ -4415,7 +4415,7 @@
         <p:spPr>
           <a:xfrm>
             <a:off x="4722266" y="3703320"/>
-            <a:ext cx="2747162" cy="594360"/>
+            <a:ext cx="2747162" cy="731520"/>
           </a:xfrm>
           <a:prstGeom prst="rect">
             <a:avLst/>
@@ -4454,7 +4454,7 @@
         <p:spPr>
           <a:xfrm>
             <a:off x="8127797" y="1554480"/>
-            <a:ext cx="3515258" cy="2880360"/>
+            <a:ext cx="3515258" cy="3063240"/>
           </a:xfrm>
           <a:prstGeom prst="rect">
             <a:avLst/>
@@ -4567,7 +4567,7 @@
         <p:spPr>
           <a:xfrm>
             <a:off x="8511845" y="3703320"/>
-            <a:ext cx="2747162" cy="594360"/>
+            <a:ext cx="2747162" cy="731520"/>
           </a:xfrm>
           <a:prstGeom prst="rect">
             <a:avLst/>

</xml_diff>